<commit_message>
Lezione 6: PostgreSQL 18 al posto della 17
</commit_message>
<xml_diff>
--- a/slide/slide-6-rds.pptx
+++ b/slide/slide-6-rds.pptx
@@ -1139,7 +1139,7 @@
           <a:p>
             <a:r>
               <a:rPr lang="en-US" dirty="0"/>
-              <a:t>Il codice, in due parti. Il subnet group: l'elenco delle subnet database, con un'espressione for come nella lezione 3. Poi il database: identifier è il nome in AWS; engine postgres; engine_version 17, solo la versione principale, la minore la sceglie e aggiorna AWS; instance_class db.t4g.micro, piccola e Graviton come il server. Il disco: 20 GB iniziali, cresce da solo fino a 100, gp3, cifrato. Il primo database si chiama app, l'utente dbadmin, e la password non c'è: la genera RDS.</a:t>
+              <a:t>Il codice, in due parti. Il subnet group: l'elenco delle subnet database, con un'espressione for come nella lezione 3. Poi il database: identifier è il nome in AWS; engine postgres; engine_version 18, solo la versione principale, la minore la sceglie e aggiorna AWS; instance_class db.t4g.micro, piccola e Graviton come il server. Il disco: 20 GB iniziali, cresce da solo fino a 100, gp3, cifrato. Il primo database si chiama app, l'utente dbadmin, e la password non c'è: la genera RDS.</a:t>
             </a:r>
             <a:endParaRPr lang="en-US" dirty="0"/>
           </a:p>
@@ -8940,7 +8940,7 @@
                 <a:ea typeface="Courier New" pitchFamily="34" charset="-122"/>
                 <a:cs typeface="Courier New" pitchFamily="34" charset="-120"/>
               </a:rPr>
-              <a:t># "17"</a:t>
+              <a:t># "18"</a:t>
             </a:r>
             <a:endParaRPr lang="en-US" sz="1600" dirty="0"/>
           </a:p>

</xml_diff>

<commit_message>
Review: README rifatto (prerequisiti per lezione, distruggere o lasciare acceso); slide divise e rinumerate (8 GitHub, 9 server, 10 allarmi, 11 EFS)
</commit_message>
<xml_diff>
--- a/slide/slide-6-rds.pptx
+++ b/slide/slide-6-rds.pptx
@@ -1933,7 +1933,7 @@
           <a:p>
             <a:r>
               <a:rPr lang="en-US" dirty="0"/>
-              <a:t>Riassumendo. Il materiale di studio è la dispensa 6, con il codice completo di rds.tf e secrets.tf spiegato blocco per blocco e l'esercizio con tutti i comandi. La prossima volta prepariamo il bucket S3 da cui il server scaricherà le nuove versioni dell'applicazione.</a:t>
+              <a:t>Riassumendo. Il materiale di studio è la dispensa 6, con il codice completo di rds.tf e secrets.tf spiegato blocco per blocco e l'esercizio con tutti i comandi. La prossima volta prepariamo i due magazzini da cui il server prenderà l'applicazione: ECR per le immagini e S3 per i file di deploy.</a:t>
             </a:r>
             <a:endParaRPr lang="en-US" dirty="0"/>
           </a:p>
@@ -17629,7 +17629,7 @@
                 <a:ea typeface="Calibri" pitchFamily="34" charset="-122"/>
                 <a:cs typeface="Calibri" pitchFamily="34" charset="-120"/>
               </a:rPr>
-              <a:t>S3: il repository degli artefatti</a:t>
+              <a:t>Immagini e artefatti: ECR e S3</a:t>
             </a:r>
             <a:endParaRPr lang="en-US" sz="1400" dirty="0"/>
           </a:p>
@@ -20680,7 +20680,7 @@
                           <a:ea typeface="Calibri" pitchFamily="34" charset="-122"/>
                           <a:cs typeface="Calibri" pitchFamily="34" charset="-120"/>
                         </a:rPr>
-                        <a:t>da 1 a 15</a:t>
+                        <a:t>una o più</a:t>
                       </a:r>
                       <a:endParaRPr lang="en-US" sz="1600" dirty="0">
                         <a:latin typeface="Calibri" charset="0"/>

</xml_diff>